<commit_message>
Update thesis presentation with images
Co-authored-by: daniyal.jamal <daniyal.jamal@heptasoftwaresolutions.com>
</commit_message>
<xml_diff>
--- a/thesis.pptx
+++ b/thesis.pptx
@@ -35707,308 +35707,6 @@
           <a:chExt cx="0" cy="0"/>
         </a:xfrm>
       </p:grpSpPr>
-      <p:sp useBgFill="1">
-        <p:nvSpPr>
-          <p:cNvPr id="19" name="Rectangle 18">
-            <a:extLst>
-              <a:ext uri="{FF2B5EF4-FFF2-40B4-BE49-F238E27FC236}">
-                <a16:creationId xmlns:a16="http://schemas.microsoft.com/office/drawing/2014/main" id="{BACC6370-2D7E-4714-9D71-7542949D7D5D}"/>
-              </a:ext>
-              <a:ext uri="{C183D7F6-B498-43B3-948B-1728B52AA6E4}">
-                <adec:decorative xmlns:adec="http://schemas.microsoft.com/office/drawing/2017/decorative" val="1"/>
-              </a:ext>
-            </a:extLst>
-          </p:cNvPr>
-          <p:cNvSpPr>
-            <a:spLocks noGrp="1" noRot="1" noChangeAspect="1" noMove="1" noResize="1" noEditPoints="1" noAdjustHandles="1" noChangeArrowheads="1" noChangeShapeType="1" noTextEdit="1"/>
-          </p:cNvSpPr>
-          <p:nvPr>
-            <p:extLst>
-              <p:ext uri="{386F3935-93C4-4BCD-93E2-E3B085C9AB24}">
-                <p16:designElem xmlns:p16="http://schemas.microsoft.com/office/powerpoint/2015/main" val="1"/>
-              </p:ext>
-            </p:extLst>
-          </p:nvPr>
-        </p:nvSpPr>
-        <p:spPr>
-          <a:xfrm>
-            <a:off x="0" y="0"/>
-            <a:ext cx="12192000" cy="6858000"/>
-          </a:xfrm>
-          <a:prstGeom prst="rect">
-            <a:avLst/>
-          </a:prstGeom>
-          <a:ln w="12700" cap="flat" cmpd="sng" algn="ctr">
-            <a:noFill/>
-            <a:prstDash val="solid"/>
-            <a:miter lim="800000"/>
-          </a:ln>
-          <a:effectLst/>
-          <a:extLst>
-            <a:ext uri="{91240B29-F687-4F45-9708-019B960494DF}">
-              <a14:hiddenLine xmlns:a14="http://schemas.microsoft.com/office/drawing/2010/main" w="12700" cap="flat" cmpd="sng" algn="ctr">
-                <a:solidFill>
-                  <a:schemeClr val="accent1">
-                    <a:shade val="50000"/>
-                  </a:schemeClr>
-                </a:solidFill>
-                <a:prstDash val="solid"/>
-                <a:miter lim="800000"/>
-              </a14:hiddenLine>
-            </a:ext>
-          </a:extLst>
-        </p:spPr>
-        <p:style>
-          <a:lnRef idx="2">
-            <a:schemeClr val="accent1">
-              <a:shade val="50000"/>
-            </a:schemeClr>
-          </a:lnRef>
-          <a:fillRef idx="1">
-            <a:schemeClr val="accent1"/>
-          </a:fillRef>
-          <a:effectRef idx="0">
-            <a:schemeClr val="accent1"/>
-          </a:effectRef>
-          <a:fontRef idx="minor">
-            <a:schemeClr val="lt1"/>
-          </a:fontRef>
-        </p:style>
-        <p:txBody>
-          <a:bodyPr rtlCol="0" anchor="ctr"/>
-          <a:lstStyle/>
-          <a:p>
-            <a:pPr algn="ctr"/>
-            <a:endParaRPr lang="en-US"/>
-          </a:p>
-        </p:txBody>
-      </p:sp>
-      <p:sp>
-        <p:nvSpPr>
-          <p:cNvPr id="20" name="Rectangle 19">
-            <a:extLst>
-              <a:ext uri="{FF2B5EF4-FFF2-40B4-BE49-F238E27FC236}">
-                <a16:creationId xmlns:a16="http://schemas.microsoft.com/office/drawing/2014/main" id="{F68B3F68-107C-434F-AA38-110D5EA91B85}"/>
-              </a:ext>
-              <a:ext uri="{C183D7F6-B498-43B3-948B-1728B52AA6E4}">
-                <adec:decorative xmlns:adec="http://schemas.microsoft.com/office/drawing/2017/decorative" val="1"/>
-              </a:ext>
-            </a:extLst>
-          </p:cNvPr>
-          <p:cNvSpPr>
-            <a:spLocks noGrp="1" noRot="1" noChangeAspect="1" noMove="1" noResize="1" noEditPoints="1" noAdjustHandles="1" noChangeArrowheads="1" noChangeShapeType="1" noTextEdit="1"/>
-          </p:cNvSpPr>
-          <p:nvPr>
-            <p:extLst>
-              <p:ext uri="{386F3935-93C4-4BCD-93E2-E3B085C9AB24}">
-                <p16:designElem xmlns:p16="http://schemas.microsoft.com/office/powerpoint/2015/main" val="1"/>
-              </p:ext>
-            </p:extLst>
-          </p:nvPr>
-        </p:nvSpPr>
-        <p:spPr>
-          <a:xfrm flipH="1">
-            <a:off x="2" y="0"/>
-            <a:ext cx="12191998" cy="1575955"/>
-          </a:xfrm>
-          <a:prstGeom prst="rect">
-            <a:avLst/>
-          </a:prstGeom>
-          <a:gradFill>
-            <a:gsLst>
-              <a:gs pos="0">
-                <a:srgbClr val="000000">
-                  <a:alpha val="96000"/>
-                </a:srgbClr>
-              </a:gs>
-              <a:gs pos="100000">
-                <a:schemeClr val="accent1">
-                  <a:lumMod val="75000"/>
-                </a:schemeClr>
-              </a:gs>
-            </a:gsLst>
-            <a:lin ang="8400000" scaled="0"/>
-          </a:gradFill>
-          <a:ln>
-            <a:noFill/>
-          </a:ln>
-        </p:spPr>
-        <p:style>
-          <a:lnRef idx="2">
-            <a:schemeClr val="accent1">
-              <a:shade val="50000"/>
-            </a:schemeClr>
-          </a:lnRef>
-          <a:fillRef idx="1">
-            <a:schemeClr val="accent1"/>
-          </a:fillRef>
-          <a:effectRef idx="0">
-            <a:schemeClr val="accent1"/>
-          </a:effectRef>
-          <a:fontRef idx="minor">
-            <a:schemeClr val="lt1"/>
-          </a:fontRef>
-        </p:style>
-        <p:txBody>
-          <a:bodyPr rtlCol="0" anchor="ctr"/>
-          <a:lstStyle/>
-          <a:p>
-            <a:pPr algn="ctr"/>
-            <a:endParaRPr lang="en-US"/>
-          </a:p>
-        </p:txBody>
-      </p:sp>
-      <p:sp>
-        <p:nvSpPr>
-          <p:cNvPr id="21" name="Rectangle 20">
-            <a:extLst>
-              <a:ext uri="{FF2B5EF4-FFF2-40B4-BE49-F238E27FC236}">
-                <a16:creationId xmlns:a16="http://schemas.microsoft.com/office/drawing/2014/main" id="{AAD0DBB9-1A4B-4391-81D4-CB19F9AB918A}"/>
-              </a:ext>
-              <a:ext uri="{C183D7F6-B498-43B3-948B-1728B52AA6E4}">
-                <adec:decorative xmlns:adec="http://schemas.microsoft.com/office/drawing/2017/decorative" val="1"/>
-              </a:ext>
-            </a:extLst>
-          </p:cNvPr>
-          <p:cNvSpPr>
-            <a:spLocks noGrp="1" noRot="1" noChangeAspect="1" noMove="1" noResize="1" noEditPoints="1" noAdjustHandles="1" noChangeArrowheads="1" noChangeShapeType="1" noTextEdit="1"/>
-          </p:cNvSpPr>
-          <p:nvPr>
-            <p:extLst>
-              <p:ext uri="{386F3935-93C4-4BCD-93E2-E3B085C9AB24}">
-                <p16:designElem xmlns:p16="http://schemas.microsoft.com/office/powerpoint/2015/main" val="1"/>
-              </p:ext>
-            </p:extLst>
-          </p:nvPr>
-        </p:nvSpPr>
-        <p:spPr>
-          <a:xfrm rot="10800000" flipH="1">
-            <a:off x="8128857" y="0"/>
-            <a:ext cx="4063143" cy="1576412"/>
-          </a:xfrm>
-          <a:prstGeom prst="rect">
-            <a:avLst/>
-          </a:prstGeom>
-          <a:gradFill>
-            <a:gsLst>
-              <a:gs pos="19000">
-                <a:schemeClr val="accent1">
-                  <a:lumMod val="50000"/>
-                  <a:alpha val="68000"/>
-                </a:schemeClr>
-              </a:gs>
-              <a:gs pos="100000">
-                <a:schemeClr val="accent1">
-                  <a:alpha val="79000"/>
-                </a:schemeClr>
-              </a:gs>
-            </a:gsLst>
-            <a:lin ang="19200000" scaled="0"/>
-          </a:gradFill>
-          <a:ln>
-            <a:noFill/>
-          </a:ln>
-        </p:spPr>
-        <p:style>
-          <a:lnRef idx="2">
-            <a:schemeClr val="accent1">
-              <a:shade val="50000"/>
-            </a:schemeClr>
-          </a:lnRef>
-          <a:fillRef idx="1">
-            <a:schemeClr val="accent1"/>
-          </a:fillRef>
-          <a:effectRef idx="0">
-            <a:schemeClr val="accent1"/>
-          </a:effectRef>
-          <a:fontRef idx="minor">
-            <a:schemeClr val="lt1"/>
-          </a:fontRef>
-        </p:style>
-        <p:txBody>
-          <a:bodyPr rtlCol="0" anchor="ctr"/>
-          <a:lstStyle/>
-          <a:p>
-            <a:pPr algn="ctr"/>
-            <a:endParaRPr lang="en-US"/>
-          </a:p>
-        </p:txBody>
-      </p:sp>
-      <p:sp>
-        <p:nvSpPr>
-          <p:cNvPr id="22" name="Rectangle 21">
-            <a:extLst>
-              <a:ext uri="{FF2B5EF4-FFF2-40B4-BE49-F238E27FC236}">
-                <a16:creationId xmlns:a16="http://schemas.microsoft.com/office/drawing/2014/main" id="{063BBA22-50EA-4C4D-BE05-F1CE4E63AA56}"/>
-              </a:ext>
-              <a:ext uri="{C183D7F6-B498-43B3-948B-1728B52AA6E4}">
-                <adec:decorative xmlns:adec="http://schemas.microsoft.com/office/drawing/2017/decorative" val="1"/>
-              </a:ext>
-            </a:extLst>
-          </p:cNvPr>
-          <p:cNvSpPr>
-            <a:spLocks noGrp="1" noRot="1" noChangeAspect="1" noMove="1" noResize="1" noEditPoints="1" noAdjustHandles="1" noChangeArrowheads="1" noChangeShapeType="1" noTextEdit="1"/>
-          </p:cNvSpPr>
-          <p:nvPr>
-            <p:extLst>
-              <p:ext uri="{386F3935-93C4-4BCD-93E2-E3B085C9AB24}">
-                <p16:designElem xmlns:p16="http://schemas.microsoft.com/office/powerpoint/2015/main" val="1"/>
-              </p:ext>
-            </p:extLst>
-          </p:nvPr>
-        </p:nvSpPr>
-        <p:spPr>
-          <a:xfrm rot="5400000">
-            <a:off x="5307777" y="-5307778"/>
-            <a:ext cx="1576446" cy="12192002"/>
-          </a:xfrm>
-          <a:prstGeom prst="rect">
-            <a:avLst/>
-          </a:prstGeom>
-          <a:gradFill>
-            <a:gsLst>
-              <a:gs pos="23000">
-                <a:schemeClr val="accent1">
-                  <a:alpha val="0"/>
-                </a:schemeClr>
-              </a:gs>
-              <a:gs pos="99000">
-                <a:srgbClr val="000000">
-                  <a:alpha val="74000"/>
-                </a:srgbClr>
-              </a:gs>
-            </a:gsLst>
-            <a:lin ang="20400000" scaled="0"/>
-          </a:gradFill>
-          <a:ln>
-            <a:noFill/>
-          </a:ln>
-        </p:spPr>
-        <p:style>
-          <a:lnRef idx="2">
-            <a:schemeClr val="accent1">
-              <a:shade val="50000"/>
-            </a:schemeClr>
-          </a:lnRef>
-          <a:fillRef idx="1">
-            <a:schemeClr val="accent1"/>
-          </a:fillRef>
-          <a:effectRef idx="0">
-            <a:schemeClr val="accent1"/>
-          </a:effectRef>
-          <a:fontRef idx="minor">
-            <a:schemeClr val="lt1"/>
-          </a:fontRef>
-        </p:style>
-        <p:txBody>
-          <a:bodyPr rtlCol="0" anchor="ctr"/>
-          <a:lstStyle/>
-          <a:p>
-            <a:pPr algn="ctr"/>
-            <a:endParaRPr lang="en-US" dirty="0"/>
-          </a:p>
-        </p:txBody>
-      </p:sp>
       <p:sp>
         <p:nvSpPr>
           <p:cNvPr id="2" name="Title 1">
@@ -36043,332 +35741,9 @@
           </a:p>
         </p:txBody>
       </p:sp>
-      <p:graphicFrame>
-        <p:nvGraphicFramePr>
-          <p:cNvPr id="3" name="Table 2">
-            <a:extLst>
-              <a:ext uri="{FF2B5EF4-FFF2-40B4-BE49-F238E27FC236}">
-                <a16:creationId xmlns:a16="http://schemas.microsoft.com/office/drawing/2014/main" id="{020D785F-D444-5B76-03B0-745F181C0154}"/>
-              </a:ext>
-            </a:extLst>
-          </p:cNvPr>
-          <p:cNvGraphicFramePr>
-            <a:graphicFrameLocks noGrp="1"/>
-          </p:cNvGraphicFramePr>
-          <p:nvPr>
-            <p:extLst>
-              <p:ext uri="{D42A27DB-BD31-4B8C-83A1-F6EECF244321}">
-                <p14:modId xmlns:p14="http://schemas.microsoft.com/office/powerpoint/2010/main" val="3276485183"/>
-              </p:ext>
-            </p:extLst>
-          </p:nvPr>
-        </p:nvGraphicFramePr>
-        <p:xfrm>
-          <a:off x="1481355" y="5222413"/>
-          <a:ext cx="9229288" cy="426720"/>
-        </p:xfrm>
-        <a:graphic>
-          <a:graphicData uri="http://schemas.openxmlformats.org/drawingml/2006/table">
-            <a:tbl>
-              <a:tblPr firstRow="1" bandRow="1">
-                <a:tableStyleId>{9D7B26C5-4107-4FEC-AEDC-1716B250A1EF}</a:tableStyleId>
-              </a:tblPr>
-              <a:tblGrid>
-                <a:gridCol w="2143588">
-                  <a:extLst>
-                    <a:ext uri="{9D8B030D-6E8A-4147-A177-3AD203B41FA5}">
-                      <a16:colId xmlns:a16="http://schemas.microsoft.com/office/drawing/2014/main" val="2540686507"/>
-                    </a:ext>
-                  </a:extLst>
-                </a:gridCol>
-                <a:gridCol w="2046514">
-                  <a:extLst>
-                    <a:ext uri="{9D8B030D-6E8A-4147-A177-3AD203B41FA5}">
-                      <a16:colId xmlns:a16="http://schemas.microsoft.com/office/drawing/2014/main" val="1391225805"/>
-                    </a:ext>
-                  </a:extLst>
-                </a:gridCol>
-                <a:gridCol w="2481943">
-                  <a:extLst>
-                    <a:ext uri="{9D8B030D-6E8A-4147-A177-3AD203B41FA5}">
-                      <a16:colId xmlns:a16="http://schemas.microsoft.com/office/drawing/2014/main" val="786911416"/>
-                    </a:ext>
-                  </a:extLst>
-                </a:gridCol>
-                <a:gridCol w="2557243">
-                  <a:extLst>
-                    <a:ext uri="{9D8B030D-6E8A-4147-A177-3AD203B41FA5}">
-                      <a16:colId xmlns:a16="http://schemas.microsoft.com/office/drawing/2014/main" val="1395319916"/>
-                    </a:ext>
-                  </a:extLst>
-                </a:gridCol>
-              </a:tblGrid>
-              <a:tr h="370840">
-                <a:tc>
-                  <a:txBody>
-                    <a:bodyPr/>
-                    <a:lstStyle/>
-                    <a:p>
-                      <a:r>
-                        <a:rPr lang="en-US" sz="2200" dirty="0"/>
-                        <a:t>Average</a:t>
-                      </a:r>
-                      <a:endParaRPr lang="en-PK" sz="2200" dirty="0"/>
-                    </a:p>
-                  </a:txBody>
-                  <a:tcPr>
-                    <a:lnL w="12700" cap="flat" cmpd="sng" algn="ctr">
-                      <a:solidFill>
-                        <a:schemeClr val="tx1"/>
-                      </a:solidFill>
-                      <a:prstDash val="solid"/>
-                      <a:round/>
-                      <a:headEnd type="none" w="med" len="med"/>
-                      <a:tailEnd type="none" w="med" len="med"/>
-                    </a:lnL>
-                    <a:lnR w="12700" cap="flat" cmpd="sng" algn="ctr">
-                      <a:solidFill>
-                        <a:schemeClr val="tx1"/>
-                      </a:solidFill>
-                      <a:prstDash val="solid"/>
-                      <a:round/>
-                      <a:headEnd type="none" w="med" len="med"/>
-                      <a:tailEnd type="none" w="med" len="med"/>
-                    </a:lnR>
-                    <a:lnT w="12700" cap="flat" cmpd="sng" algn="ctr">
-                      <a:solidFill>
-                        <a:schemeClr val="tx1"/>
-                      </a:solidFill>
-                      <a:prstDash val="solid"/>
-                      <a:round/>
-                      <a:headEnd type="none" w="med" len="med"/>
-                      <a:tailEnd type="none" w="med" len="med"/>
-                    </a:lnT>
-                    <a:lnB w="12700" cap="flat" cmpd="sng" algn="ctr">
-                      <a:solidFill>
-                        <a:schemeClr val="tx1"/>
-                      </a:solidFill>
-                      <a:prstDash val="solid"/>
-                      <a:round/>
-                      <a:headEnd type="none" w="med" len="med"/>
-                      <a:tailEnd type="none" w="med" len="med"/>
-                    </a:lnB>
-                  </a:tcPr>
-                </a:tc>
-                <a:tc>
-                  <a:txBody>
-                    <a:bodyPr/>
-                    <a:lstStyle/>
-                    <a:p>
-                      <a:pPr algn="just">
-                        <a:lnSpc>
-                          <a:spcPct val="115000"/>
-                        </a:lnSpc>
-                        <a:spcAft>
-                          <a:spcPts val="800"/>
-                        </a:spcAft>
-                        <a:buNone/>
-                      </a:pPr>
-                      <a:r>
-                        <a:rPr lang="en-PK" sz="2200" b="1" kern="100" dirty="0">
-                          <a:effectLst/>
-                        </a:rPr>
-                        <a:t>98.61</a:t>
-                      </a:r>
-                      <a:endParaRPr lang="en-PK" sz="2200" b="1" kern="100" dirty="0">
-                        <a:effectLst/>
-                        <a:latin typeface="Aptos" panose="020B0004020202020204" pitchFamily="34" charset="0"/>
-                        <a:ea typeface="Aptos" panose="020B0004020202020204" pitchFamily="34" charset="0"/>
-                        <a:cs typeface="Times New Roman" panose="02020603050405020304" pitchFamily="18" charset="0"/>
-                      </a:endParaRPr>
-                    </a:p>
-                  </a:txBody>
-                  <a:tcPr marL="197794" marR="197794" marT="0" marB="0">
-                    <a:lnL w="12700" cap="flat" cmpd="sng" algn="ctr">
-                      <a:solidFill>
-                        <a:schemeClr val="tx1"/>
-                      </a:solidFill>
-                      <a:prstDash val="solid"/>
-                      <a:round/>
-                      <a:headEnd type="none" w="med" len="med"/>
-                      <a:tailEnd type="none" w="med" len="med"/>
-                    </a:lnL>
-                    <a:lnR w="12700" cap="flat" cmpd="sng" algn="ctr">
-                      <a:solidFill>
-                        <a:schemeClr val="tx1"/>
-                      </a:solidFill>
-                      <a:prstDash val="solid"/>
-                      <a:round/>
-                      <a:headEnd type="none" w="med" len="med"/>
-                      <a:tailEnd type="none" w="med" len="med"/>
-                    </a:lnR>
-                    <a:lnT w="12700" cap="flat" cmpd="sng" algn="ctr">
-                      <a:solidFill>
-                        <a:schemeClr val="tx1"/>
-                      </a:solidFill>
-                      <a:prstDash val="solid"/>
-                      <a:round/>
-                      <a:headEnd type="none" w="med" len="med"/>
-                      <a:tailEnd type="none" w="med" len="med"/>
-                    </a:lnT>
-                    <a:lnB w="12700" cap="flat" cmpd="sng" algn="ctr">
-                      <a:solidFill>
-                        <a:schemeClr val="tx1"/>
-                      </a:solidFill>
-                      <a:prstDash val="solid"/>
-                      <a:round/>
-                      <a:headEnd type="none" w="med" len="med"/>
-                      <a:tailEnd type="none" w="med" len="med"/>
-                    </a:lnB>
-                  </a:tcPr>
-                </a:tc>
-                <a:tc>
-                  <a:txBody>
-                    <a:bodyPr/>
-                    <a:lstStyle/>
-                    <a:p>
-                      <a:pPr algn="just">
-                        <a:lnSpc>
-                          <a:spcPct val="115000"/>
-                        </a:lnSpc>
-                        <a:spcAft>
-                          <a:spcPts val="800"/>
-                        </a:spcAft>
-                        <a:buNone/>
-                      </a:pPr>
-                      <a:r>
-                        <a:rPr lang="en-US" sz="2200" kern="100" dirty="0">
-                          <a:effectLst/>
-                        </a:rPr>
-                        <a:t>0.984</a:t>
-                      </a:r>
-                      <a:endParaRPr lang="en-PK" sz="2200" kern="100" dirty="0">
-                        <a:effectLst/>
-                        <a:latin typeface="Aptos" panose="020B0004020202020204" pitchFamily="34" charset="0"/>
-                        <a:ea typeface="Aptos" panose="020B0004020202020204" pitchFamily="34" charset="0"/>
-                        <a:cs typeface="Times New Roman" panose="02020603050405020304" pitchFamily="18" charset="0"/>
-                      </a:endParaRPr>
-                    </a:p>
-                  </a:txBody>
-                  <a:tcPr marL="197794" marR="197794" marT="0" marB="0">
-                    <a:lnL w="12700" cap="flat" cmpd="sng" algn="ctr">
-                      <a:solidFill>
-                        <a:schemeClr val="tx1"/>
-                      </a:solidFill>
-                      <a:prstDash val="solid"/>
-                      <a:round/>
-                      <a:headEnd type="none" w="med" len="med"/>
-                      <a:tailEnd type="none" w="med" len="med"/>
-                    </a:lnL>
-                    <a:lnR w="12700" cap="flat" cmpd="sng" algn="ctr">
-                      <a:solidFill>
-                        <a:schemeClr val="tx1"/>
-                      </a:solidFill>
-                      <a:prstDash val="solid"/>
-                      <a:round/>
-                      <a:headEnd type="none" w="med" len="med"/>
-                      <a:tailEnd type="none" w="med" len="med"/>
-                    </a:lnR>
-                    <a:lnT w="12700" cap="flat" cmpd="sng" algn="ctr">
-                      <a:solidFill>
-                        <a:schemeClr val="tx1"/>
-                      </a:solidFill>
-                      <a:prstDash val="solid"/>
-                      <a:round/>
-                      <a:headEnd type="none" w="med" len="med"/>
-                      <a:tailEnd type="none" w="med" len="med"/>
-                    </a:lnT>
-                    <a:lnB w="12700" cap="flat" cmpd="sng" algn="ctr">
-                      <a:solidFill>
-                        <a:schemeClr val="tx1"/>
-                      </a:solidFill>
-                      <a:prstDash val="solid"/>
-                      <a:round/>
-                      <a:headEnd type="none" w="med" len="med"/>
-                      <a:tailEnd type="none" w="med" len="med"/>
-                    </a:lnB>
-                  </a:tcPr>
-                </a:tc>
-                <a:tc>
-                  <a:txBody>
-                    <a:bodyPr/>
-                    <a:lstStyle/>
-                    <a:p>
-                      <a:pPr algn="just">
-                        <a:lnSpc>
-                          <a:spcPct val="115000"/>
-                        </a:lnSpc>
-                        <a:spcAft>
-                          <a:spcPts val="800"/>
-                        </a:spcAft>
-                        <a:buNone/>
-                      </a:pPr>
-                      <a:r>
-                        <a:rPr lang="en-US" sz="2200" b="1" kern="100" dirty="0">
-                          <a:effectLst/>
-                        </a:rPr>
-                        <a:t>0.988</a:t>
-                      </a:r>
-                      <a:endParaRPr lang="en-PK" sz="2200" b="1" kern="100" dirty="0">
-                        <a:effectLst/>
-                        <a:latin typeface="Aptos" panose="020B0004020202020204" pitchFamily="34" charset="0"/>
-                        <a:ea typeface="Aptos" panose="020B0004020202020204" pitchFamily="34" charset="0"/>
-                        <a:cs typeface="Times New Roman" panose="02020603050405020304" pitchFamily="18" charset="0"/>
-                      </a:endParaRPr>
-                    </a:p>
-                  </a:txBody>
-                  <a:tcPr marL="197794" marR="197794" marT="0" marB="0">
-                    <a:lnL w="12700" cap="flat" cmpd="sng" algn="ctr">
-                      <a:solidFill>
-                        <a:schemeClr val="tx1"/>
-                      </a:solidFill>
-                      <a:prstDash val="solid"/>
-                      <a:round/>
-                      <a:headEnd type="none" w="med" len="med"/>
-                      <a:tailEnd type="none" w="med" len="med"/>
-                    </a:lnL>
-                    <a:lnR w="12700" cap="flat" cmpd="sng" algn="ctr">
-                      <a:solidFill>
-                        <a:schemeClr val="tx1"/>
-                      </a:solidFill>
-                      <a:prstDash val="solid"/>
-                      <a:round/>
-                      <a:headEnd type="none" w="med" len="med"/>
-                      <a:tailEnd type="none" w="med" len="med"/>
-                    </a:lnR>
-                    <a:lnT w="12700" cap="flat" cmpd="sng" algn="ctr">
-                      <a:solidFill>
-                        <a:schemeClr val="tx1"/>
-                      </a:solidFill>
-                      <a:prstDash val="solid"/>
-                      <a:round/>
-                      <a:headEnd type="none" w="med" len="med"/>
-                      <a:tailEnd type="none" w="med" len="med"/>
-                    </a:lnT>
-                    <a:lnB w="12700" cap="flat" cmpd="sng" algn="ctr">
-                      <a:solidFill>
-                        <a:schemeClr val="tx1"/>
-                      </a:solidFill>
-                      <a:prstDash val="solid"/>
-                      <a:round/>
-                      <a:headEnd type="none" w="med" len="med"/>
-                      <a:tailEnd type="none" w="med" len="med"/>
-                    </a:lnB>
-                  </a:tcPr>
-                </a:tc>
-                <a:extLst>
-                  <a:ext uri="{0D108BD9-81ED-4DB2-BD59-A6C34878D82A}">
-                    <a16:rowId xmlns:a16="http://schemas.microsoft.com/office/drawing/2014/main" val="1827387277"/>
-                  </a:ext>
-                </a:extLst>
-              </a:tr>
-            </a:tbl>
-          </a:graphicData>
-        </a:graphic>
-      </p:graphicFrame>
       <p:pic>
         <p:nvPicPr>
-          <p:cNvPr id="23" name="Picture 22" descr="fig_compile.png"/>
+          <p:cNvPr id="3" name="Picture 2" descr="image.png"/>
           <p:cNvPicPr>
             <a:picLocks noChangeAspect="1"/>
           </p:cNvPicPr>
@@ -36382,8 +35757,8 @@
         </p:blipFill>
         <p:spPr>
           <a:xfrm>
-            <a:off x="1481356" y="1924820"/>
-            <a:ext cx="9229287" cy="2774526"/>
+            <a:off x="548640" y="1409474"/>
+            <a:ext cx="11094720" cy="6698502"/>
           </a:xfrm>
           <a:prstGeom prst="rect">
             <a:avLst/>
@@ -36449,63 +35824,9 @@
           </a:p>
         </p:txBody>
       </p:sp>
-      <p:sp>
-        <p:nvSpPr>
-          <p:cNvPr id="7" name="Text Placeholder 6">
-            <a:extLst>
-              <a:ext uri="{FF2B5EF4-FFF2-40B4-BE49-F238E27FC236}">
-                <a16:creationId xmlns:a16="http://schemas.microsoft.com/office/drawing/2014/main" id="{FD7490B4-1985-A71B-8F09-45A30A9AED06}"/>
-              </a:ext>
-            </a:extLst>
-          </p:cNvPr>
-          <p:cNvSpPr>
-            <a:spLocks noGrp="1"/>
-          </p:cNvSpPr>
-          <p:nvPr>
-            <p:ph type="body" idx="1"/>
-          </p:nvPr>
-        </p:nvSpPr>
-        <p:spPr/>
-        <p:txBody>
-          <a:bodyPr/>
-          <a:lstStyle/>
-          <a:p>
-            <a:r>
-              <a:t>Key match observed in host log</a:t>
-            </a:r>
-          </a:p>
-        </p:txBody>
-      </p:sp>
-      <p:sp>
-        <p:nvSpPr>
-          <p:cNvPr id="8" name="Text Placeholder 7">
-            <a:extLst>
-              <a:ext uri="{FF2B5EF4-FFF2-40B4-BE49-F238E27FC236}">
-                <a16:creationId xmlns:a16="http://schemas.microsoft.com/office/drawing/2014/main" id="{5DE0254B-4EFB-B501-0CB5-9A95C64469E2}"/>
-              </a:ext>
-            </a:extLst>
-          </p:cNvPr>
-          <p:cNvSpPr>
-            <a:spLocks noGrp="1"/>
-          </p:cNvSpPr>
-          <p:nvPr>
-            <p:ph type="body" sz="quarter" idx="3"/>
-          </p:nvPr>
-        </p:nvSpPr>
-        <p:spPr/>
-        <p:txBody>
-          <a:bodyPr/>
-          <a:lstStyle/>
-          <a:p>
-            <a:r>
-              <a:t>Debug enabled only after match</a:t>
-            </a:r>
-          </a:p>
-        </p:txBody>
-      </p:sp>
       <p:pic>
         <p:nvPicPr>
-          <p:cNvPr id="12" name="Picture 11" descr="fig_keymatch.png"/>
+          <p:cNvPr id="7" name="Picture 6" descr="image.png"/>
           <p:cNvPicPr>
             <a:picLocks noChangeAspect="1"/>
           </p:cNvPicPr>
@@ -36519,8 +35840,8 @@
         </p:blipFill>
         <p:spPr>
           <a:xfrm>
-            <a:off x="0" y="2450647"/>
-            <a:ext cx="6384272" cy="4042228"/>
+            <a:off x="457200" y="2477428"/>
+            <a:ext cx="5501640" cy="3319512"/>
           </a:xfrm>
           <a:prstGeom prst="rect">
             <a:avLst/>
@@ -36529,7 +35850,7 @@
       </p:pic>
       <p:pic>
         <p:nvPicPr>
-          <p:cNvPr id="13" name="Picture 12" descr="fig_debugenabled.png"/>
+          <p:cNvPr id="8" name="Picture 7" descr="image.png"/>
           <p:cNvPicPr>
             <a:picLocks noChangeAspect="1"/>
           </p:cNvPicPr>
@@ -36543,8 +35864,8 @@
         </p:blipFill>
         <p:spPr>
           <a:xfrm>
-            <a:off x="5997575" y="2505075"/>
-            <a:ext cx="6052911" cy="3942188"/>
+            <a:off x="6233160" y="2471668"/>
+            <a:ext cx="5501640" cy="3331031"/>
           </a:xfrm>
           <a:prstGeom prst="rect">
             <a:avLst/>
@@ -37190,14 +36511,14 @@
           <a:lstStyle/>
           <a:p>
             <a:r>
-              <a:t>Firmware Inspection (HEX)</a:t>
+              <a:t>Firmware Inspection and Fail-Stop</a:t>
             </a:r>
           </a:p>
         </p:txBody>
       </p:sp>
       <p:pic>
         <p:nvPicPr>
-          <p:cNvPr id="3" name="Picture 2" descr="fig_hex.png"/>
+          <p:cNvPr id="3" name="Picture 2" descr="image.png"/>
           <p:cNvPicPr>
             <a:picLocks noChangeAspect="1"/>
           </p:cNvPicPr>
@@ -37211,8 +36532,32 @@
         </p:blipFill>
         <p:spPr>
           <a:xfrm>
-            <a:off x="3114654" y="1825625"/>
-            <a:ext cx="5962692" cy="4351338"/>
+            <a:off x="457200" y="2476311"/>
+            <a:ext cx="5501640" cy="3321745"/>
+          </a:xfrm>
+          <a:prstGeom prst="rect">
+            <a:avLst/>
+          </a:prstGeom>
+        </p:spPr>
+      </p:pic>
+      <p:pic>
+        <p:nvPicPr>
+          <p:cNvPr id="4" name="Picture 3" descr="image.png"/>
+          <p:cNvPicPr>
+            <a:picLocks noChangeAspect="1"/>
+          </p:cNvPicPr>
+          <p:nvPr/>
+        </p:nvPicPr>
+        <p:blipFill>
+          <a:blip r:embed="rId4"/>
+          <a:stretch>
+            <a:fillRect/>
+          </a:stretch>
+        </p:blipFill>
+        <p:spPr>
+          <a:xfrm>
+            <a:off x="6233160" y="2965095"/>
+            <a:ext cx="5501640" cy="2344177"/>
           </a:xfrm>
           <a:prstGeom prst="rect">
             <a:avLst/>
@@ -37257,308 +36602,6 @@
           <a:chExt cx="0" cy="0"/>
         </a:xfrm>
       </p:grpSpPr>
-      <p:sp useBgFill="1">
-        <p:nvSpPr>
-          <p:cNvPr id="16" name="Rectangle 15">
-            <a:extLst>
-              <a:ext uri="{FF2B5EF4-FFF2-40B4-BE49-F238E27FC236}">
-                <a16:creationId xmlns:a16="http://schemas.microsoft.com/office/drawing/2014/main" id="{BACC6370-2D7E-4714-9D71-7542949D7D5D}"/>
-              </a:ext>
-              <a:ext uri="{C183D7F6-B498-43B3-948B-1728B52AA6E4}">
-                <adec:decorative xmlns:adec="http://schemas.microsoft.com/office/drawing/2017/decorative" val="1"/>
-              </a:ext>
-            </a:extLst>
-          </p:cNvPr>
-          <p:cNvSpPr>
-            <a:spLocks noGrp="1" noRot="1" noChangeAspect="1" noMove="1" noResize="1" noEditPoints="1" noAdjustHandles="1" noChangeArrowheads="1" noChangeShapeType="1" noTextEdit="1"/>
-          </p:cNvSpPr>
-          <p:nvPr>
-            <p:extLst>
-              <p:ext uri="{386F3935-93C4-4BCD-93E2-E3B085C9AB24}">
-                <p16:designElem xmlns:p16="http://schemas.microsoft.com/office/powerpoint/2015/main" val="1"/>
-              </p:ext>
-            </p:extLst>
-          </p:nvPr>
-        </p:nvSpPr>
-        <p:spPr>
-          <a:xfrm>
-            <a:off x="0" y="0"/>
-            <a:ext cx="12192000" cy="6858000"/>
-          </a:xfrm>
-          <a:prstGeom prst="rect">
-            <a:avLst/>
-          </a:prstGeom>
-          <a:ln w="12700" cap="flat" cmpd="sng" algn="ctr">
-            <a:noFill/>
-            <a:prstDash val="solid"/>
-            <a:miter lim="800000"/>
-          </a:ln>
-          <a:effectLst/>
-          <a:extLst>
-            <a:ext uri="{91240B29-F687-4F45-9708-019B960494DF}">
-              <a14:hiddenLine xmlns:a14="http://schemas.microsoft.com/office/drawing/2010/main" w="12700" cap="flat" cmpd="sng" algn="ctr">
-                <a:solidFill>
-                  <a:schemeClr val="accent1">
-                    <a:shade val="50000"/>
-                  </a:schemeClr>
-                </a:solidFill>
-                <a:prstDash val="solid"/>
-                <a:miter lim="800000"/>
-              </a14:hiddenLine>
-            </a:ext>
-          </a:extLst>
-        </p:spPr>
-        <p:style>
-          <a:lnRef idx="2">
-            <a:schemeClr val="accent1">
-              <a:shade val="50000"/>
-            </a:schemeClr>
-          </a:lnRef>
-          <a:fillRef idx="1">
-            <a:schemeClr val="accent1"/>
-          </a:fillRef>
-          <a:effectRef idx="0">
-            <a:schemeClr val="accent1"/>
-          </a:effectRef>
-          <a:fontRef idx="minor">
-            <a:schemeClr val="lt1"/>
-          </a:fontRef>
-        </p:style>
-        <p:txBody>
-          <a:bodyPr rtlCol="0" anchor="ctr"/>
-          <a:lstStyle/>
-          <a:p>
-            <a:pPr algn="ctr"/>
-            <a:endParaRPr lang="en-US"/>
-          </a:p>
-        </p:txBody>
-      </p:sp>
-      <p:sp>
-        <p:nvSpPr>
-          <p:cNvPr id="18" name="Rectangle 17">
-            <a:extLst>
-              <a:ext uri="{FF2B5EF4-FFF2-40B4-BE49-F238E27FC236}">
-                <a16:creationId xmlns:a16="http://schemas.microsoft.com/office/drawing/2014/main" id="{F68B3F68-107C-434F-AA38-110D5EA91B85}"/>
-              </a:ext>
-              <a:ext uri="{C183D7F6-B498-43B3-948B-1728B52AA6E4}">
-                <adec:decorative xmlns:adec="http://schemas.microsoft.com/office/drawing/2017/decorative" val="1"/>
-              </a:ext>
-            </a:extLst>
-          </p:cNvPr>
-          <p:cNvSpPr>
-            <a:spLocks noGrp="1" noRot="1" noChangeAspect="1" noMove="1" noResize="1" noEditPoints="1" noAdjustHandles="1" noChangeArrowheads="1" noChangeShapeType="1" noTextEdit="1"/>
-          </p:cNvSpPr>
-          <p:nvPr>
-            <p:extLst>
-              <p:ext uri="{386F3935-93C4-4BCD-93E2-E3B085C9AB24}">
-                <p16:designElem xmlns:p16="http://schemas.microsoft.com/office/powerpoint/2015/main" val="1"/>
-              </p:ext>
-            </p:extLst>
-          </p:nvPr>
-        </p:nvSpPr>
-        <p:spPr>
-          <a:xfrm flipH="1">
-            <a:off x="2" y="0"/>
-            <a:ext cx="12191998" cy="1575955"/>
-          </a:xfrm>
-          <a:prstGeom prst="rect">
-            <a:avLst/>
-          </a:prstGeom>
-          <a:gradFill>
-            <a:gsLst>
-              <a:gs pos="0">
-                <a:srgbClr val="000000">
-                  <a:alpha val="96000"/>
-                </a:srgbClr>
-              </a:gs>
-              <a:gs pos="100000">
-                <a:schemeClr val="accent1">
-                  <a:lumMod val="75000"/>
-                </a:schemeClr>
-              </a:gs>
-            </a:gsLst>
-            <a:lin ang="8400000" scaled="0"/>
-          </a:gradFill>
-          <a:ln>
-            <a:noFill/>
-          </a:ln>
-        </p:spPr>
-        <p:style>
-          <a:lnRef idx="2">
-            <a:schemeClr val="accent1">
-              <a:shade val="50000"/>
-            </a:schemeClr>
-          </a:lnRef>
-          <a:fillRef idx="1">
-            <a:schemeClr val="accent1"/>
-          </a:fillRef>
-          <a:effectRef idx="0">
-            <a:schemeClr val="accent1"/>
-          </a:effectRef>
-          <a:fontRef idx="minor">
-            <a:schemeClr val="lt1"/>
-          </a:fontRef>
-        </p:style>
-        <p:txBody>
-          <a:bodyPr rtlCol="0" anchor="ctr"/>
-          <a:lstStyle/>
-          <a:p>
-            <a:pPr algn="ctr"/>
-            <a:endParaRPr lang="en-US"/>
-          </a:p>
-        </p:txBody>
-      </p:sp>
-      <p:sp>
-        <p:nvSpPr>
-          <p:cNvPr id="20" name="Rectangle 19">
-            <a:extLst>
-              <a:ext uri="{FF2B5EF4-FFF2-40B4-BE49-F238E27FC236}">
-                <a16:creationId xmlns:a16="http://schemas.microsoft.com/office/drawing/2014/main" id="{AAD0DBB9-1A4B-4391-81D4-CB19F9AB918A}"/>
-              </a:ext>
-              <a:ext uri="{C183D7F6-B498-43B3-948B-1728B52AA6E4}">
-                <adec:decorative xmlns:adec="http://schemas.microsoft.com/office/drawing/2017/decorative" val="1"/>
-              </a:ext>
-            </a:extLst>
-          </p:cNvPr>
-          <p:cNvSpPr>
-            <a:spLocks noGrp="1" noRot="1" noChangeAspect="1" noMove="1" noResize="1" noEditPoints="1" noAdjustHandles="1" noChangeArrowheads="1" noChangeShapeType="1" noTextEdit="1"/>
-          </p:cNvSpPr>
-          <p:nvPr>
-            <p:extLst>
-              <p:ext uri="{386F3935-93C4-4BCD-93E2-E3B085C9AB24}">
-                <p16:designElem xmlns:p16="http://schemas.microsoft.com/office/powerpoint/2015/main" val="1"/>
-              </p:ext>
-            </p:extLst>
-          </p:nvPr>
-        </p:nvSpPr>
-        <p:spPr>
-          <a:xfrm rot="10800000" flipH="1">
-            <a:off x="8128857" y="0"/>
-            <a:ext cx="4063143" cy="1576412"/>
-          </a:xfrm>
-          <a:prstGeom prst="rect">
-            <a:avLst/>
-          </a:prstGeom>
-          <a:gradFill>
-            <a:gsLst>
-              <a:gs pos="19000">
-                <a:schemeClr val="accent1">
-                  <a:lumMod val="50000"/>
-                  <a:alpha val="68000"/>
-                </a:schemeClr>
-              </a:gs>
-              <a:gs pos="100000">
-                <a:schemeClr val="accent1">
-                  <a:alpha val="79000"/>
-                </a:schemeClr>
-              </a:gs>
-            </a:gsLst>
-            <a:lin ang="19200000" scaled="0"/>
-          </a:gradFill>
-          <a:ln>
-            <a:noFill/>
-          </a:ln>
-        </p:spPr>
-        <p:style>
-          <a:lnRef idx="2">
-            <a:schemeClr val="accent1">
-              <a:shade val="50000"/>
-            </a:schemeClr>
-          </a:lnRef>
-          <a:fillRef idx="1">
-            <a:schemeClr val="accent1"/>
-          </a:fillRef>
-          <a:effectRef idx="0">
-            <a:schemeClr val="accent1"/>
-          </a:effectRef>
-          <a:fontRef idx="minor">
-            <a:schemeClr val="lt1"/>
-          </a:fontRef>
-        </p:style>
-        <p:txBody>
-          <a:bodyPr rtlCol="0" anchor="ctr"/>
-          <a:lstStyle/>
-          <a:p>
-            <a:pPr algn="ctr"/>
-            <a:endParaRPr lang="en-US"/>
-          </a:p>
-        </p:txBody>
-      </p:sp>
-      <p:sp>
-        <p:nvSpPr>
-          <p:cNvPr id="22" name="Rectangle 21">
-            <a:extLst>
-              <a:ext uri="{FF2B5EF4-FFF2-40B4-BE49-F238E27FC236}">
-                <a16:creationId xmlns:a16="http://schemas.microsoft.com/office/drawing/2014/main" id="{063BBA22-50EA-4C4D-BE05-F1CE4E63AA56}"/>
-              </a:ext>
-              <a:ext uri="{C183D7F6-B498-43B3-948B-1728B52AA6E4}">
-                <adec:decorative xmlns:adec="http://schemas.microsoft.com/office/drawing/2017/decorative" val="1"/>
-              </a:ext>
-            </a:extLst>
-          </p:cNvPr>
-          <p:cNvSpPr>
-            <a:spLocks noGrp="1" noRot="1" noChangeAspect="1" noMove="1" noResize="1" noEditPoints="1" noAdjustHandles="1" noChangeArrowheads="1" noChangeShapeType="1" noTextEdit="1"/>
-          </p:cNvSpPr>
-          <p:nvPr>
-            <p:extLst>
-              <p:ext uri="{386F3935-93C4-4BCD-93E2-E3B085C9AB24}">
-                <p16:designElem xmlns:p16="http://schemas.microsoft.com/office/powerpoint/2015/main" val="1"/>
-              </p:ext>
-            </p:extLst>
-          </p:nvPr>
-        </p:nvSpPr>
-        <p:spPr>
-          <a:xfrm rot="5400000">
-            <a:off x="5307777" y="-5307778"/>
-            <a:ext cx="1576446" cy="12192002"/>
-          </a:xfrm>
-          <a:prstGeom prst="rect">
-            <a:avLst/>
-          </a:prstGeom>
-          <a:gradFill>
-            <a:gsLst>
-              <a:gs pos="23000">
-                <a:schemeClr val="accent1">
-                  <a:alpha val="0"/>
-                </a:schemeClr>
-              </a:gs>
-              <a:gs pos="99000">
-                <a:srgbClr val="000000">
-                  <a:alpha val="74000"/>
-                </a:srgbClr>
-              </a:gs>
-            </a:gsLst>
-            <a:lin ang="20400000" scaled="0"/>
-          </a:gradFill>
-          <a:ln>
-            <a:noFill/>
-          </a:ln>
-        </p:spPr>
-        <p:style>
-          <a:lnRef idx="2">
-            <a:schemeClr val="accent1">
-              <a:shade val="50000"/>
-            </a:schemeClr>
-          </a:lnRef>
-          <a:fillRef idx="1">
-            <a:schemeClr val="accent1"/>
-          </a:fillRef>
-          <a:effectRef idx="0">
-            <a:schemeClr val="accent1"/>
-          </a:effectRef>
-          <a:fontRef idx="minor">
-            <a:schemeClr val="lt1"/>
-          </a:fontRef>
-        </p:style>
-        <p:txBody>
-          <a:bodyPr rtlCol="0" anchor="ctr"/>
-          <a:lstStyle/>
-          <a:p>
-            <a:pPr algn="ctr"/>
-            <a:endParaRPr lang="en-US" dirty="0"/>
-          </a:p>
-        </p:txBody>
-      </p:sp>
       <p:sp>
         <p:nvSpPr>
           <p:cNvPr id="2" name="Title 1">
@@ -37595,7 +36638,31 @@
       </p:sp>
       <p:pic>
         <p:nvPicPr>
-          <p:cNvPr id="23" name="Picture 22" descr="fig_loadimage.png"/>
+          <p:cNvPr id="3" name="Picture 2" descr="image.png"/>
+          <p:cNvPicPr>
+            <a:picLocks noChangeAspect="1"/>
+          </p:cNvPicPr>
+          <p:nvPr/>
+        </p:nvPicPr>
+        <p:blipFill>
+          <a:blip r:embed="rId3"/>
+          <a:stretch>
+            <a:fillRect/>
+          </a:stretch>
+        </p:blipFill>
+        <p:spPr>
+          <a:xfrm>
+            <a:off x="457200" y="2104287"/>
+            <a:ext cx="5501640" cy="3601700"/>
+          </a:xfrm>
+          <a:prstGeom prst="rect">
+            <a:avLst/>
+          </a:prstGeom>
+        </p:spPr>
+      </p:pic>
+      <p:pic>
+        <p:nvPicPr>
+          <p:cNvPr id="4" name="Picture 3" descr="image.png"/>
           <p:cNvPicPr>
             <a:picLocks noChangeAspect="1"/>
           </p:cNvPicPr>
@@ -37609,8 +36676,8 @@
         </p:blipFill>
         <p:spPr>
           <a:xfrm>
-            <a:off x="402771" y="2112579"/>
-            <a:ext cx="11440886" cy="4192808"/>
+            <a:off x="6233160" y="2651739"/>
+            <a:ext cx="5501640" cy="2506796"/>
           </a:xfrm>
           <a:prstGeom prst="rect">
             <a:avLst/>
@@ -39989,66 +39056,6 @@
           <a:chExt cx="0" cy="0"/>
         </a:xfrm>
       </p:grpSpPr>
-      <p:sp useBgFill="1">
-        <p:nvSpPr>
-          <p:cNvPr id="13" name="Slide Background">
-            <a:extLst>
-              <a:ext uri="{FF2B5EF4-FFF2-40B4-BE49-F238E27FC236}">
-                <a16:creationId xmlns:a16="http://schemas.microsoft.com/office/drawing/2014/main" id="{9F7D5CDA-D291-4307-BF55-1381FED29634}"/>
-              </a:ext>
-              <a:ext uri="{C183D7F6-B498-43B3-948B-1728B52AA6E4}">
-                <adec:decorative xmlns:adec="http://schemas.microsoft.com/office/drawing/2017/decorative" val="1"/>
-              </a:ext>
-            </a:extLst>
-          </p:cNvPr>
-          <p:cNvSpPr>
-            <a:spLocks noGrp="1" noRot="1" noChangeAspect="1" noMove="1" noResize="1" noEditPoints="1" noAdjustHandles="1" noChangeArrowheads="1" noChangeShapeType="1" noTextEdit="1"/>
-          </p:cNvSpPr>
-          <p:nvPr>
-            <p:extLst>
-              <p:ext uri="{386F3935-93C4-4BCD-93E2-E3B085C9AB24}">
-                <p16:designElem xmlns:p16="http://schemas.microsoft.com/office/powerpoint/2015/main" val="1"/>
-              </p:ext>
-            </p:extLst>
-          </p:nvPr>
-        </p:nvSpPr>
-        <p:spPr>
-          <a:xfrm>
-            <a:off x="0" y="0"/>
-            <a:ext cx="12192000" cy="6858000"/>
-          </a:xfrm>
-          <a:prstGeom prst="rect">
-            <a:avLst/>
-          </a:prstGeom>
-          <a:ln>
-            <a:noFill/>
-          </a:ln>
-        </p:spPr>
-        <p:style>
-          <a:lnRef idx="2">
-            <a:schemeClr val="accent1">
-              <a:shade val="50000"/>
-            </a:schemeClr>
-          </a:lnRef>
-          <a:fillRef idx="1">
-            <a:schemeClr val="accent1"/>
-          </a:fillRef>
-          <a:effectRef idx="0">
-            <a:schemeClr val="accent1"/>
-          </a:effectRef>
-          <a:fontRef idx="minor">
-            <a:schemeClr val="lt1"/>
-          </a:fontRef>
-        </p:style>
-        <p:txBody>
-          <a:bodyPr rtlCol="0" anchor="ctr"/>
-          <a:lstStyle/>
-          <a:p>
-            <a:pPr algn="ctr"/>
-            <a:endParaRPr lang="en-US"/>
-          </a:p>
-        </p:txBody>
-      </p:sp>
       <p:sp>
         <p:nvSpPr>
           <p:cNvPr id="2" name="Title 1">
@@ -40083,89 +39090,9 @@
           </a:p>
         </p:txBody>
       </p:sp>
-      <p:sp>
-        <p:nvSpPr>
-          <p:cNvPr id="6" name="Rectangle 1">
-            <a:extLst>
-              <a:ext uri="{FF2B5EF4-FFF2-40B4-BE49-F238E27FC236}">
-                <a16:creationId xmlns:a16="http://schemas.microsoft.com/office/drawing/2014/main" id="{A4E6203A-5BF5-8D52-FBBA-17A8B3194BB5}"/>
-              </a:ext>
-            </a:extLst>
-          </p:cNvPr>
-          <p:cNvSpPr>
-            <a:spLocks noGrp="1" noChangeArrowheads="1"/>
-          </p:cNvSpPr>
-          <p:nvPr>
-            <p:ph type="body" sz="half" idx="2"/>
-          </p:nvPr>
-        </p:nvSpPr>
-        <p:spPr bwMode="auto">
-          <a:xfrm>
-            <a:off x="761800" y="2470244"/>
-            <a:ext cx="5334197" cy="3769835"/>
-          </a:xfrm>
-          <a:prstGeom prst="rect">
-            <a:avLst/>
-          </a:prstGeom>
-          <a:extLst>
-            <a:ext uri="{909E8E84-426E-40DD-AFC4-6F175D3DCCD1}">
-              <a14:hiddenFill xmlns:a14="http://schemas.microsoft.com/office/drawing/2010/main">
-                <a:solidFill>
-                  <a:schemeClr val="accent1"/>
-                </a:solidFill>
-              </a14:hiddenFill>
-            </a:ext>
-            <a:ext uri="{91240B29-F687-4F45-9708-019B960494DF}">
-              <a14:hiddenLine xmlns:a14="http://schemas.microsoft.com/office/drawing/2010/main" w="9525">
-                <a:solidFill>
-                  <a:schemeClr val="tx1"/>
-                </a:solidFill>
-                <a:miter lim="800000"/>
-                <a:headEnd/>
-                <a:tailEnd/>
-              </a14:hiddenLine>
-            </a:ext>
-            <a:ext uri="{AF507438-7753-43E0-B8FC-AC1667EBCBE1}">
-              <a14:hiddenEffects xmlns:a14="http://schemas.microsoft.com/office/drawing/2010/main">
-                <a:effectLst>
-                  <a:outerShdw dist="35921" dir="2700000" algn="ctr" rotWithShape="0">
-                    <a:schemeClr val="bg2"/>
-                  </a:outerShdw>
-                </a:effectLst>
-              </a14:hiddenEffects>
-            </a:ext>
-          </a:extLst>
-        </p:spPr>
-        <p:txBody>
-          <a:bodyPr vert="horz" lIns="91440" tIns="45720" rIns="91440" bIns="45720" numCol="1" rtlCol="0" anchor="ctr" anchorCtr="0" compatLnSpc="1">
-            <a:prstTxWarp prst="textNoShape">
-              <a:avLst/>
-            </a:prstTxWarp>
-            <a:normAutofit/>
-          </a:bodyPr>
-          <a:lstStyle/>
-          <a:p>
-            <a:r>
-              <a:t>Host toolchain and UART authorization sequence</a:t>
-            </a:r>
-          </a:p>
-          <a:p>
-            <a:pPr/>
-            <a:r>
-              <a:t>Protected NVM and comparator on-device</a:t>
-            </a:r>
-          </a:p>
-          <a:p>
-            <a:pPr/>
-            <a:r>
-              <a:t>FSM gates execution and debug enablement</a:t>
-            </a:r>
-          </a:p>
-        </p:txBody>
-      </p:sp>
       <p:pic>
         <p:nvPicPr>
-          <p:cNvPr id="14" name="Picture 13" descr="fig_arch_flow.png"/>
+          <p:cNvPr id="3" name="Picture 2" descr="image.png"/>
           <p:cNvPicPr>
             <a:picLocks noChangeAspect="1"/>
           </p:cNvPicPr>
@@ -40179,8 +39106,8 @@
         </p:blipFill>
         <p:spPr>
           <a:xfrm>
-            <a:off x="6857797" y="-10886"/>
-            <a:ext cx="5334204" cy="6868886"/>
+            <a:off x="548640" y="2653123"/>
+            <a:ext cx="11094720" cy="6185275"/>
           </a:xfrm>
           <a:prstGeom prst="rect">
             <a:avLst/>

</xml_diff>